<commit_message>
changes for PPT and DOCX export
</commit_message>
<xml_diff>
--- a/backend/template/Resume_master_with_placeholders.pptx
+++ b/backend/template/Resume_master_with_placeholders.pptx
@@ -275,7 +275,7 @@
           <a:p>
             <a:fld id="{187B8588-1665-0A4A-AD47-68FFFFC620D1}" type="datetimeFigureOut">
               <a:rPr kumimoji="1" lang="ja-JP" altLang="en-US" smtClean="0"/>
-              <a:t>2026/4/19</a:t>
+              <a:t>2026/4/20</a:t>
             </a:fld>
             <a:endParaRPr kumimoji="1" lang="ja-JP" altLang="en-US"/>
           </a:p>
@@ -8788,8 +8788,8 @@
         </p:nvSpPr>
         <p:spPr>
           <a:xfrm>
-            <a:off x="239486" y="452653"/>
-            <a:ext cx="5562599" cy="612475"/>
+            <a:off x="335360" y="628906"/>
+            <a:ext cx="5562599" cy="307777"/>
           </a:xfrm>
           <a:prstGeom prst="rect">
             <a:avLst/>
@@ -8802,45 +8802,63 @@
           </a:bodyPr>
           <a:lstStyle/>
           <a:p>
-            <a:pPr marL="0" marR="0" indent="0" algn="l" defTabSz="914400" rtl="0" eaLnBrk="1" fontAlgn="base" latinLnBrk="0" hangingPunct="1">
-              <a:lnSpc>
-                <a:spcPct val="90000"/>
-              </a:lnSpc>
-              <a:spcBef>
-                <a:spcPts val="600"/>
-              </a:spcBef>
-              <a:spcAft>
-                <a:spcPts val="0"/>
-              </a:spcAft>
-              <a:buClr>
-                <a:srgbClr val="0085C3"/>
-              </a:buClr>
-              <a:buSzTx/>
-              <a:buFontTx/>
-              <a:buNone/>
-              <a:tabLst/>
-              <a:defRPr/>
-            </a:pPr>
-            <a:r>
-              <a:rPr sz="1400">
+            <a:r>
+              <a:rPr sz="1400" b="1" dirty="0">
                 <a:solidFill>
                   <a:srgbClr val="070F26"/>
                 </a:solidFill>
                 <a:latin typeface="Arial"/>
               </a:rPr>
-              <a:t>{{cvDraft.header.jobTitle}}</a:t>
-            </a:r>
-          </a:p>
-          <a:p>
-            <a:r>
-              <a:rPr sz="1400">
+              <a:t>{{</a:t>
+            </a:r>
+            <a:r>
+              <a:rPr sz="1400" b="1" dirty="0" err="1">
                 <a:solidFill>
                   <a:srgbClr val="070F26"/>
                 </a:solidFill>
                 <a:latin typeface="Arial"/>
               </a:rPr>
-              <a:t>{{cvDraft.header.fullName}}</a:t>
-            </a:r>
+              <a:t>cvDraft.header.fullName</a:t>
+            </a:r>
+            <a:r>
+              <a:rPr sz="1400" b="1" dirty="0">
+                <a:solidFill>
+                  <a:srgbClr val="070F26"/>
+                </a:solidFill>
+                <a:latin typeface="Arial"/>
+              </a:rPr>
+              <a:t>}}</a:t>
+            </a:r>
+            <a:r>
+              <a:rPr lang="en-US" sz="1400" b="1" dirty="0">
+                <a:solidFill>
+                  <a:srgbClr val="070F26"/>
+                </a:solidFill>
+              </a:rPr>
+              <a:t> | {{</a:t>
+            </a:r>
+            <a:r>
+              <a:rPr lang="en-US" sz="1400" b="1" dirty="0" err="1">
+                <a:solidFill>
+                  <a:srgbClr val="070F26"/>
+                </a:solidFill>
+              </a:rPr>
+              <a:t>cvDraft.header.jobTitle</a:t>
+            </a:r>
+            <a:r>
+              <a:rPr lang="en-US" sz="1400" b="1" dirty="0">
+                <a:solidFill>
+                  <a:srgbClr val="070F26"/>
+                </a:solidFill>
+              </a:rPr>
+              <a:t>}}</a:t>
+            </a:r>
+            <a:endParaRPr sz="1400" b="1" dirty="0">
+              <a:solidFill>
+                <a:srgbClr val="070F26"/>
+              </a:solidFill>
+              <a:latin typeface="Arial"/>
+            </a:endParaRPr>
           </a:p>
         </p:txBody>
       </p:sp>
@@ -11366,15 +11384,6 @@
 </file>
 
 <file path=customXml/item1.xml><?xml version="1.0" encoding="utf-8"?>
-<?mso-contentType ?>
-<FormTemplates xmlns="http://schemas.microsoft.com/sharepoint/v3/contenttype/forms">
-  <Display>DocumentLibraryForm</Display>
-  <Edit>DocumentLibraryForm</Edit>
-  <New>DocumentLibraryForm</New>
-</FormTemplates>
-</file>
-
-<file path=customXml/item2.xml><?xml version="1.0" encoding="utf-8"?>
 <ct:contentTypeSchema xmlns:ct="http://schemas.microsoft.com/office/2006/metadata/contentType" xmlns:ma="http://schemas.microsoft.com/office/2006/metadata/properties/metaAttributes" ct:_="" ma:_="" ma:contentTypeName="Document" ma:contentTypeID="0x010100D0564508D67C8C449A42AC4556ED8F47" ma:contentTypeVersion="14" ma:contentTypeDescription="Create a new document." ma:contentTypeScope="" ma:versionID="3ff91eae5bfb167f4fd3ce960cf07781">
   <xsd:schema xmlns:xsd="http://www.w3.org/2001/XMLSchema" xmlns:xs="http://www.w3.org/2001/XMLSchema" xmlns:p="http://schemas.microsoft.com/office/2006/metadata/properties" xmlns:ns2="b6ef1051-416b-4c61-92ca-e2ba97173a0a" xmlns:ns3="09960d75-8a19-463f-a971-1239e8fc591d" targetNamespace="http://schemas.microsoft.com/office/2006/metadata/properties" ma:root="true" ma:fieldsID="865119611a2d976ecb2e106be994d03b" ns2:_="" ns3:_="">
     <xsd:import namespace="b6ef1051-416b-4c61-92ca-e2ba97173a0a"/>
@@ -11603,6 +11612,15 @@
 </ct:contentTypeSchema>
 </file>
 
+<file path=customXml/item2.xml><?xml version="1.0" encoding="utf-8"?>
+<?mso-contentType ?>
+<FormTemplates xmlns="http://schemas.microsoft.com/sharepoint/v3/contenttype/forms">
+  <Display>DocumentLibraryForm</Display>
+  <Edit>DocumentLibraryForm</Edit>
+  <New>DocumentLibraryForm</New>
+</FormTemplates>
+</file>
+
 <file path=customXml/item3.xml><?xml version="1.0" encoding="utf-8"?>
 <p:properties xmlns:p="http://schemas.microsoft.com/office/2006/metadata/properties" xmlns:xsi="http://www.w3.org/2001/XMLSchema-instance" xmlns:pc="http://schemas.microsoft.com/office/infopath/2007/PartnerControls">
   <documentManagement>
@@ -11615,14 +11633,6 @@
 </file>
 
 <file path=customXml/itemProps1.xml><?xml version="1.0" encoding="utf-8"?>
-<ds:datastoreItem xmlns:ds="http://schemas.openxmlformats.org/officeDocument/2006/customXml" ds:itemID="{452DDBF3-664C-4EA4-86B8-FA1419EDE7E4}">
-  <ds:schemaRefs>
-    <ds:schemaRef ds:uri="http://schemas.microsoft.com/sharepoint/v3/contenttype/forms"/>
-  </ds:schemaRefs>
-</ds:datastoreItem>
-</file>
-
-<file path=customXml/itemProps2.xml><?xml version="1.0" encoding="utf-8"?>
 <ds:datastoreItem xmlns:ds="http://schemas.openxmlformats.org/officeDocument/2006/customXml" ds:itemID="{3B5A1E3B-4736-4E1A-9017-ADAB1747CEE2}">
   <ds:schemaRefs>
     <ds:schemaRef ds:uri="09960d75-8a19-463f-a971-1239e8fc591d"/>
@@ -11637,6 +11647,14 @@
     <ds:schemaRef ds:uri="http://schemas.microsoft.com/office/infopath/2007/PartnerControls"/>
     <ds:schemaRef ds:uri="http://schemas.openxmlformats.org/package/2006/metadata/core-properties"/>
     <ds:schemaRef ds:uri="http://www.w3.org/2001/XMLSchema"/>
+  </ds:schemaRefs>
+</ds:datastoreItem>
+</file>
+
+<file path=customXml/itemProps2.xml><?xml version="1.0" encoding="utf-8"?>
+<ds:datastoreItem xmlns:ds="http://schemas.openxmlformats.org/officeDocument/2006/customXml" ds:itemID="{452DDBF3-664C-4EA4-86B8-FA1419EDE7E4}">
+  <ds:schemaRefs>
+    <ds:schemaRef ds:uri="http://schemas.microsoft.com/sharepoint/v3/contenttype/forms"/>
   </ds:schemaRefs>
 </ds:datastoreItem>
 </file>

</xml_diff>